<commit_message>
feat(pptx-deck): theme mode/style token + 反 AI 痕迹审美负面清单
theme yaml 加可选 mode(light|dark 暗色模板语义)+ style(sharp/soft/rounded/pill
风格配方,数值表落 _base.py STYLE_RECIPES),apply_theme 推到 module 常量
供 layout 渐进读取。visual-qa.md 字体检查换成 audit_pptx.py 全量机械审计
(替代抽 5 页 grep 抽样),卡片圆角改按 theme style 判断而非写死 0.05,
新增反 AI 痕迹负面清单(标题装饰线 / 正文居中 / 纯文字页 3 项)。

Co-Authored-By: Claude Sonnet 5 <noreply@anthropic.com>
</commit_message>
<xml_diff>
--- a/.claude/skills/pptx-deck/examples/sample_output.pptx
+++ b/.claude/skills/pptx-deck/examples/sample_output.pptx
@@ -3140,14 +3140,401 @@
       </p:sp>
       <p:sp>
         <p:nvSpPr>
-          <p:cNvPr id="3" name="TextBox 2"/>
+          <p:cNvPr id="3" name="Oval 2"/>
+          <p:cNvSpPr/>
+          <p:nvPr/>
+        </p:nvSpPr>
+        <p:spPr>
+          <a:xfrm>
+            <a:off x="8991295" y="-3017520"/>
+            <a:ext cx="6949440" cy="6949440"/>
+          </a:xfrm>
+          <a:prstGeom prst="ellipse">
+            <a:avLst/>
+          </a:prstGeom>
+          <a:solidFill>
+            <a:srgbClr val="1D3C5C"/>
+          </a:solidFill>
+          <a:ln>
+            <a:noFill/>
+          </a:ln>
+        </p:spPr>
+        <p:style>
+          <a:lnRef idx="1">
+            <a:schemeClr val="accent1"/>
+          </a:lnRef>
+          <a:fillRef idx="3">
+            <a:schemeClr val="accent1"/>
+          </a:fillRef>
+          <a:effectRef idx="2">
+            <a:schemeClr val="accent1"/>
+          </a:effectRef>
+          <a:fontRef idx="minor">
+            <a:schemeClr val="lt1"/>
+          </a:fontRef>
+        </p:style>
+        <p:txBody>
+          <a:bodyPr rtlCol="0" anchor="ctr"/>
+          <a:lstStyle/>
+          <a:p>
+            <a:pPr algn="ctr"/>
+          </a:p>
+        </p:txBody>
+      </p:sp>
+      <p:sp>
+        <p:nvSpPr>
+          <p:cNvPr id="4" name="Oval 3"/>
+          <p:cNvSpPr/>
+          <p:nvPr/>
+        </p:nvSpPr>
+        <p:spPr>
+          <a:xfrm>
+            <a:off x="10088575" y="-1920240"/>
+            <a:ext cx="4754880" cy="4754880"/>
+          </a:xfrm>
+          <a:prstGeom prst="ellipse">
+            <a:avLst/>
+          </a:prstGeom>
+          <a:solidFill>
+            <a:srgbClr val="2F4E6E"/>
+          </a:solidFill>
+          <a:ln>
+            <a:noFill/>
+          </a:ln>
+        </p:spPr>
+        <p:style>
+          <a:lnRef idx="1">
+            <a:schemeClr val="accent1"/>
+          </a:lnRef>
+          <a:fillRef idx="3">
+            <a:schemeClr val="accent1"/>
+          </a:fillRef>
+          <a:effectRef idx="2">
+            <a:schemeClr val="accent1"/>
+          </a:effectRef>
+          <a:fontRef idx="minor">
+            <a:schemeClr val="lt1"/>
+          </a:fontRef>
+        </p:style>
+        <p:txBody>
+          <a:bodyPr rtlCol="0" anchor="ctr"/>
+          <a:lstStyle/>
+          <a:p>
+            <a:pPr algn="ctr"/>
+          </a:p>
+        </p:txBody>
+      </p:sp>
+      <p:sp>
+        <p:nvSpPr>
+          <p:cNvPr id="5" name="Oval 4"/>
+          <p:cNvSpPr/>
+          <p:nvPr/>
+        </p:nvSpPr>
+        <p:spPr>
+          <a:xfrm>
+            <a:off x="11094415" y="-914400"/>
+            <a:ext cx="2743200" cy="2743200"/>
+          </a:xfrm>
+          <a:prstGeom prst="ellipse">
+            <a:avLst/>
+          </a:prstGeom>
+          <a:solidFill>
+            <a:srgbClr val="416080"/>
+          </a:solidFill>
+          <a:ln>
+            <a:noFill/>
+          </a:ln>
+        </p:spPr>
+        <p:style>
+          <a:lnRef idx="1">
+            <a:schemeClr val="accent1"/>
+          </a:lnRef>
+          <a:fillRef idx="3">
+            <a:schemeClr val="accent1"/>
+          </a:fillRef>
+          <a:effectRef idx="2">
+            <a:schemeClr val="accent1"/>
+          </a:effectRef>
+          <a:fontRef idx="minor">
+            <a:schemeClr val="lt1"/>
+          </a:fontRef>
+        </p:style>
+        <p:txBody>
+          <a:bodyPr rtlCol="0" anchor="ctr"/>
+          <a:lstStyle/>
+          <a:p>
+            <a:pPr algn="ctr"/>
+          </a:p>
+        </p:txBody>
+      </p:sp>
+      <p:sp>
+        <p:nvSpPr>
+          <p:cNvPr id="6" name="Rectangle 5"/>
+          <p:cNvSpPr/>
+          <p:nvPr/>
+        </p:nvSpPr>
+        <p:spPr>
+          <a:xfrm>
+            <a:off x="502920" y="5852160"/>
+            <a:ext cx="109728" cy="13716"/>
+          </a:xfrm>
+          <a:prstGeom prst="rect">
+            <a:avLst/>
+          </a:prstGeom>
+          <a:solidFill>
+            <a:srgbClr val="E6F0FC"/>
+          </a:solidFill>
+          <a:ln>
+            <a:noFill/>
+          </a:ln>
+        </p:spPr>
+        <p:style>
+          <a:lnRef idx="1">
+            <a:schemeClr val="accent1"/>
+          </a:lnRef>
+          <a:fillRef idx="3">
+            <a:schemeClr val="accent1"/>
+          </a:fillRef>
+          <a:effectRef idx="2">
+            <a:schemeClr val="accent1"/>
+          </a:effectRef>
+          <a:fontRef idx="minor">
+            <a:schemeClr val="lt1"/>
+          </a:fontRef>
+        </p:style>
+        <p:txBody>
+          <a:bodyPr rtlCol="0" anchor="ctr"/>
+          <a:lstStyle/>
+          <a:p>
+            <a:pPr algn="ctr"/>
+          </a:p>
+        </p:txBody>
+      </p:sp>
+      <p:sp>
+        <p:nvSpPr>
+          <p:cNvPr id="7" name="Rectangle 6"/>
+          <p:cNvSpPr/>
+          <p:nvPr/>
+        </p:nvSpPr>
+        <p:spPr>
+          <a:xfrm>
+            <a:off x="667512" y="5852160"/>
+            <a:ext cx="109728" cy="13716"/>
+          </a:xfrm>
+          <a:prstGeom prst="rect">
+            <a:avLst/>
+          </a:prstGeom>
+          <a:solidFill>
+            <a:srgbClr val="E6F0FC"/>
+          </a:solidFill>
+          <a:ln>
+            <a:noFill/>
+          </a:ln>
+        </p:spPr>
+        <p:style>
+          <a:lnRef idx="1">
+            <a:schemeClr val="accent1"/>
+          </a:lnRef>
+          <a:fillRef idx="3">
+            <a:schemeClr val="accent1"/>
+          </a:fillRef>
+          <a:effectRef idx="2">
+            <a:schemeClr val="accent1"/>
+          </a:effectRef>
+          <a:fontRef idx="minor">
+            <a:schemeClr val="lt1"/>
+          </a:fontRef>
+        </p:style>
+        <p:txBody>
+          <a:bodyPr rtlCol="0" anchor="ctr"/>
+          <a:lstStyle/>
+          <a:p>
+            <a:pPr algn="ctr"/>
+          </a:p>
+        </p:txBody>
+      </p:sp>
+      <p:sp>
+        <p:nvSpPr>
+          <p:cNvPr id="8" name="Rectangle 7"/>
+          <p:cNvSpPr/>
+          <p:nvPr/>
+        </p:nvSpPr>
+        <p:spPr>
+          <a:xfrm>
+            <a:off x="832104" y="5852160"/>
+            <a:ext cx="109728" cy="13716"/>
+          </a:xfrm>
+          <a:prstGeom prst="rect">
+            <a:avLst/>
+          </a:prstGeom>
+          <a:solidFill>
+            <a:srgbClr val="E6F0FC"/>
+          </a:solidFill>
+          <a:ln>
+            <a:noFill/>
+          </a:ln>
+        </p:spPr>
+        <p:style>
+          <a:lnRef idx="1">
+            <a:schemeClr val="accent1"/>
+          </a:lnRef>
+          <a:fillRef idx="3">
+            <a:schemeClr val="accent1"/>
+          </a:fillRef>
+          <a:effectRef idx="2">
+            <a:schemeClr val="accent1"/>
+          </a:effectRef>
+          <a:fontRef idx="minor">
+            <a:schemeClr val="lt1"/>
+          </a:fontRef>
+        </p:style>
+        <p:txBody>
+          <a:bodyPr rtlCol="0" anchor="ctr"/>
+          <a:lstStyle/>
+          <a:p>
+            <a:pPr algn="ctr"/>
+          </a:p>
+        </p:txBody>
+      </p:sp>
+      <p:sp>
+        <p:nvSpPr>
+          <p:cNvPr id="9" name="Rectangle 8"/>
+          <p:cNvSpPr/>
+          <p:nvPr/>
+        </p:nvSpPr>
+        <p:spPr>
+          <a:xfrm>
+            <a:off x="996696" y="5852160"/>
+            <a:ext cx="109728" cy="13716"/>
+          </a:xfrm>
+          <a:prstGeom prst="rect">
+            <a:avLst/>
+          </a:prstGeom>
+          <a:solidFill>
+            <a:srgbClr val="E6F0FC"/>
+          </a:solidFill>
+          <a:ln>
+            <a:noFill/>
+          </a:ln>
+        </p:spPr>
+        <p:style>
+          <a:lnRef idx="1">
+            <a:schemeClr val="accent1"/>
+          </a:lnRef>
+          <a:fillRef idx="3">
+            <a:schemeClr val="accent1"/>
+          </a:fillRef>
+          <a:effectRef idx="2">
+            <a:schemeClr val="accent1"/>
+          </a:effectRef>
+          <a:fontRef idx="minor">
+            <a:schemeClr val="lt1"/>
+          </a:fontRef>
+        </p:style>
+        <p:txBody>
+          <a:bodyPr rtlCol="0" anchor="ctr"/>
+          <a:lstStyle/>
+          <a:p>
+            <a:pPr algn="ctr"/>
+          </a:p>
+        </p:txBody>
+      </p:sp>
+      <p:sp>
+        <p:nvSpPr>
+          <p:cNvPr id="10" name="Rectangle 9"/>
+          <p:cNvSpPr/>
+          <p:nvPr/>
+        </p:nvSpPr>
+        <p:spPr>
+          <a:xfrm>
+            <a:off x="1161288" y="5852160"/>
+            <a:ext cx="109728" cy="13716"/>
+          </a:xfrm>
+          <a:prstGeom prst="rect">
+            <a:avLst/>
+          </a:prstGeom>
+          <a:solidFill>
+            <a:srgbClr val="E6F0FC"/>
+          </a:solidFill>
+          <a:ln>
+            <a:noFill/>
+          </a:ln>
+        </p:spPr>
+        <p:style>
+          <a:lnRef idx="1">
+            <a:schemeClr val="accent1"/>
+          </a:lnRef>
+          <a:fillRef idx="3">
+            <a:schemeClr val="accent1"/>
+          </a:fillRef>
+          <a:effectRef idx="2">
+            <a:schemeClr val="accent1"/>
+          </a:effectRef>
+          <a:fontRef idx="minor">
+            <a:schemeClr val="lt1"/>
+          </a:fontRef>
+        </p:style>
+        <p:txBody>
+          <a:bodyPr rtlCol="0" anchor="ctr"/>
+          <a:lstStyle/>
+          <a:p>
+            <a:pPr algn="ctr"/>
+          </a:p>
+        </p:txBody>
+      </p:sp>
+      <p:sp>
+        <p:nvSpPr>
+          <p:cNvPr id="11" name="Rectangle 10"/>
+          <p:cNvSpPr/>
+          <p:nvPr/>
+        </p:nvSpPr>
+        <p:spPr>
+          <a:xfrm>
+            <a:off x="1325880" y="5852160"/>
+            <a:ext cx="109728" cy="13716"/>
+          </a:xfrm>
+          <a:prstGeom prst="rect">
+            <a:avLst/>
+          </a:prstGeom>
+          <a:solidFill>
+            <a:srgbClr val="E6F0FC"/>
+          </a:solidFill>
+          <a:ln>
+            <a:noFill/>
+          </a:ln>
+        </p:spPr>
+        <p:style>
+          <a:lnRef idx="1">
+            <a:schemeClr val="accent1"/>
+          </a:lnRef>
+          <a:fillRef idx="3">
+            <a:schemeClr val="accent1"/>
+          </a:fillRef>
+          <a:effectRef idx="2">
+            <a:schemeClr val="accent1"/>
+          </a:effectRef>
+          <a:fontRef idx="minor">
+            <a:schemeClr val="lt1"/>
+          </a:fontRef>
+        </p:style>
+        <p:txBody>
+          <a:bodyPr rtlCol="0" anchor="ctr"/>
+          <a:lstStyle/>
+          <a:p>
+            <a:pPr algn="ctr"/>
+          </a:p>
+        </p:txBody>
+      </p:sp>
+      <p:sp>
+        <p:nvSpPr>
+          <p:cNvPr id="12" name="TextBox 11"/>
           <p:cNvSpPr txBox="1"/>
           <p:nvPr/>
         </p:nvSpPr>
         <p:spPr>
           <a:xfrm>
-            <a:off x="502920" y="2423160"/>
-            <a:ext cx="11185855" cy="1097280"/>
+            <a:off x="731520" y="2286000"/>
+            <a:ext cx="10058400" cy="1463040"/>
           </a:xfrm>
           <a:prstGeom prst="rect">
             <a:avLst/>
@@ -3162,7 +3549,7 @@
           <a:p>
             <a:pPr algn="l"/>
             <a:r>
-              <a:rPr sz="4400" b="1" i="0">
+              <a:rPr sz="5400" b="1" i="0">
                 <a:solidFill>
                   <a:srgbClr val="FFFFFF"/>
                 </a:solidFill>
@@ -3170,21 +3557,64 @@
                 <a:ea typeface="Microsoft YaHei"/>
                 <a:cs typeface="Microsoft YaHei"/>
               </a:rPr>
-              <a:t>iLovePPT v2 演示</a:t>
-            </a:r>
-          </a:p>
-        </p:txBody>
-      </p:sp>
-      <p:sp>
-        <p:nvSpPr>
-          <p:cNvPr id="4" name="TextBox 3"/>
+              <a:t>iLovePPT 示例 deck</a:t>
+            </a:r>
+          </a:p>
+        </p:txBody>
+      </p:sp>
+      <p:sp>
+        <p:nvSpPr>
+          <p:cNvPr id="13" name="Rectangle 12"/>
+          <p:cNvSpPr/>
+          <p:nvPr/>
+        </p:nvSpPr>
+        <p:spPr>
+          <a:xfrm>
+            <a:off x="731520" y="3931920"/>
+            <a:ext cx="548640" cy="36576"/>
+          </a:xfrm>
+          <a:prstGeom prst="rect">
+            <a:avLst/>
+          </a:prstGeom>
+          <a:solidFill>
+            <a:srgbClr val="007A6D"/>
+          </a:solidFill>
+          <a:ln>
+            <a:noFill/>
+          </a:ln>
+        </p:spPr>
+        <p:style>
+          <a:lnRef idx="1">
+            <a:schemeClr val="accent1"/>
+          </a:lnRef>
+          <a:fillRef idx="3">
+            <a:schemeClr val="accent1"/>
+          </a:fillRef>
+          <a:effectRef idx="2">
+            <a:schemeClr val="accent1"/>
+          </a:effectRef>
+          <a:fontRef idx="minor">
+            <a:schemeClr val="lt1"/>
+          </a:fontRef>
+        </p:style>
+        <p:txBody>
+          <a:bodyPr rtlCol="0" anchor="ctr"/>
+          <a:lstStyle/>
+          <a:p>
+            <a:pPr algn="ctr"/>
+          </a:p>
+        </p:txBody>
+      </p:sp>
+      <p:sp>
+        <p:nvSpPr>
+          <p:cNvPr id="14" name="TextBox 13"/>
           <p:cNvSpPr txBox="1"/>
           <p:nvPr/>
         </p:nvSpPr>
         <p:spPr>
           <a:xfrm>
-            <a:off x="502920" y="3794760"/>
-            <a:ext cx="11185855" cy="640080"/>
+            <a:off x="731520" y="4114800"/>
+            <a:ext cx="10058400" cy="731520"/>
           </a:xfrm>
           <a:prstGeom prst="rect">
             <a:avLst/>
@@ -3199,7 +3629,7 @@
           <a:p>
             <a:pPr algn="l"/>
             <a:r>
-              <a:rPr sz="2000" b="0" i="0">
+              <a:rPr sz="2200" b="0" i="0">
                 <a:solidFill>
                   <a:srgbClr val="E6F0FC"/>
                 </a:solidFill>
@@ -3239,7 +3669,7 @@
         <p:spPr>
           <a:xfrm>
             <a:off x="502920" y="548640"/>
-            <a:ext cx="11155680" cy="731520"/>
+            <a:ext cx="11155680" cy="822960"/>
           </a:xfrm>
           <a:prstGeom prst="rect">
             <a:avLst/>
@@ -3253,7 +3683,7 @@
           <a:lstStyle/>
           <a:p>
             <a:r>
-              <a:rPr sz="4000" b="1" i="0">
+              <a:rPr sz="4200" b="1" i="0">
                 <a:solidFill>
                   <a:srgbClr val="0B2A4A"/>
                 </a:solidFill>
@@ -3289,9 +3719,9 @@
           <a:lstStyle/>
           <a:p>
             <a:r>
-              <a:rPr sz="2600" b="1" i="0">
+              <a:rPr sz="2800" b="1" i="0">
                 <a:solidFill>
-                  <a:srgbClr val="1E6FE0"/>
+                  <a:srgbClr val="0A52BF"/>
                 </a:solidFill>
                 <a:latin typeface="Helvetica Neue"/>
                 <a:ea typeface="Helvetica Neue"/>
@@ -3325,9 +3755,9 @@
           <a:lstStyle/>
           <a:p>
             <a:r>
-              <a:rPr sz="2000" b="0" i="0">
+              <a:rPr sz="2200" b="0" i="0">
                 <a:solidFill>
-                  <a:srgbClr val="1A1A1A"/>
+                  <a:srgbClr val="4A4A4A"/>
                 </a:solidFill>
                 <a:latin typeface="Microsoft YaHei"/>
                 <a:ea typeface="Microsoft YaHei"/>
@@ -3361,9 +3791,9 @@
           <a:lstStyle/>
           <a:p>
             <a:r>
-              <a:rPr sz="2600" b="1" i="0">
+              <a:rPr sz="2800" b="1" i="0">
                 <a:solidFill>
-                  <a:srgbClr val="1E6FE0"/>
+                  <a:srgbClr val="0A52BF"/>
                 </a:solidFill>
                 <a:latin typeface="Helvetica Neue"/>
                 <a:ea typeface="Helvetica Neue"/>
@@ -3397,9 +3827,9 @@
           <a:lstStyle/>
           <a:p>
             <a:r>
-              <a:rPr sz="2000" b="0" i="0">
+              <a:rPr sz="2200" b="0" i="0">
                 <a:solidFill>
-                  <a:srgbClr val="1A1A1A"/>
+                  <a:srgbClr val="4A4A4A"/>
                 </a:solidFill>
                 <a:latin typeface="Microsoft YaHei"/>
                 <a:ea typeface="Microsoft YaHei"/>
@@ -3433,9 +3863,9 @@
           <a:lstStyle/>
           <a:p>
             <a:r>
-              <a:rPr sz="2600" b="1" i="0">
+              <a:rPr sz="2800" b="1" i="0">
                 <a:solidFill>
-                  <a:srgbClr val="1E6FE0"/>
+                  <a:srgbClr val="0A52BF"/>
                 </a:solidFill>
                 <a:latin typeface="Helvetica Neue"/>
                 <a:ea typeface="Helvetica Neue"/>
@@ -3469,9 +3899,9 @@
           <a:lstStyle/>
           <a:p>
             <a:r>
-              <a:rPr sz="2000" b="0" i="0">
+              <a:rPr sz="2200" b="0" i="0">
                 <a:solidFill>
-                  <a:srgbClr val="1A1A1A"/>
+                  <a:srgbClr val="4A4A4A"/>
                 </a:solidFill>
                 <a:latin typeface="Microsoft YaHei"/>
                 <a:ea typeface="Microsoft YaHei"/>
@@ -3555,7 +3985,7 @@
             <a:r>
               <a:rPr sz="900" b="0" i="0">
                 <a:solidFill>
-                  <a:srgbClr val="8C8C8C"/>
+                  <a:srgbClr val="6F6F6F"/>
                 </a:solidFill>
                 <a:latin typeface="Helvetica Neue"/>
                 <a:ea typeface="Helvetica Neue"/>
@@ -3586,20 +4016,57 @@
       <p:grpSpPr/>
       <p:sp>
         <p:nvSpPr>
-          <p:cNvPr id="2" name="Rectangle 1"/>
+          <p:cNvPr id="2" name="TextBox 1"/>
+          <p:cNvSpPr txBox="1"/>
+          <p:nvPr/>
+        </p:nvSpPr>
+        <p:spPr>
+          <a:xfrm>
+            <a:off x="3657600" y="274320"/>
+            <a:ext cx="8229600" cy="6400800"/>
+          </a:xfrm>
+          <a:prstGeom prst="rect">
+            <a:avLst/>
+          </a:prstGeom>
+          <a:noFill/>
+        </p:spPr>
+        <p:txBody>
+          <a:bodyPr wrap="none" lIns="0" rIns="0" tIns="0" bIns="0">
+            <a:spAutoFit/>
+          </a:bodyPr>
+          <a:lstStyle/>
+          <a:p>
+            <a:pPr algn="r"/>
+            <a:r>
+              <a:rPr sz="40000" b="1" i="0">
+                <a:solidFill>
+                  <a:srgbClr val="F2F2F2"/>
+                </a:solidFill>
+                <a:latin typeface="Helvetica Neue"/>
+                <a:ea typeface="Helvetica Neue"/>
+                <a:cs typeface="Helvetica Neue"/>
+              </a:rPr>
+              <a:t>01</a:t>
+            </a:r>
+          </a:p>
+        </p:txBody>
+      </p:sp>
+      <p:sp>
+        <p:nvSpPr>
+          <p:cNvPr id="3" name="Rectangle 2"/>
           <p:cNvSpPr/>
           <p:nvPr/>
         </p:nvSpPr>
         <p:spPr>
           <a:xfrm>
-            <a:off x="502920" y="2697480"/>
-            <a:ext cx="1463040" cy="1463040"/>
+            <a:off x="502920" y="2103120"/>
+            <a:ext cx="73152" cy="2651760"/>
           </a:xfrm>
           <a:prstGeom prst="rect">
             <a:avLst/>
           </a:prstGeom>
           <a:solidFill>
-            <a:srgbClr val="0B2A4A"/>
+            <a:srgbClr val="0A52BF"/>
           </a:solidFill>
           <a:ln>
             <a:noFill/>
@@ -3629,14 +4096,14 @@
       </p:sp>
       <p:sp>
         <p:nvSpPr>
-          <p:cNvPr id="3" name="TextBox 2"/>
+          <p:cNvPr id="4" name="TextBox 3"/>
           <p:cNvSpPr txBox="1"/>
           <p:nvPr/>
         </p:nvSpPr>
         <p:spPr>
           <a:xfrm>
-            <a:off x="502920" y="2697480"/>
-            <a:ext cx="1463040" cy="1463040"/>
+            <a:off x="777240" y="2194560"/>
+            <a:ext cx="5486400" cy="457200"/>
           </a:xfrm>
           <a:prstGeom prst="rect">
             <a:avLst/>
@@ -3644,36 +4111,36 @@
           <a:noFill/>
         </p:spPr>
         <p:txBody>
-          <a:bodyPr wrap="none" lIns="0" rIns="0" tIns="0" bIns="0">
+          <a:bodyPr wrap="square" lIns="0" rIns="0" tIns="0" bIns="0">
             <a:spAutoFit/>
           </a:bodyPr>
           <a:lstStyle/>
           <a:p>
-            <a:pPr algn="ctr"/>
-            <a:r>
-              <a:rPr sz="7200" b="1" i="0">
+            <a:pPr algn="l"/>
+            <a:r>
+              <a:rPr sz="1400" b="1" i="0">
                 <a:solidFill>
-                  <a:srgbClr val="FFFFFF"/>
+                  <a:srgbClr val="0A52BF"/>
                 </a:solidFill>
                 <a:latin typeface="Helvetica Neue"/>
                 <a:ea typeface="Helvetica Neue"/>
                 <a:cs typeface="Helvetica Neue"/>
               </a:rPr>
-              <a:t>1</a:t>
-            </a:r>
-          </a:p>
-        </p:txBody>
-      </p:sp>
-      <p:sp>
-        <p:nvSpPr>
-          <p:cNvPr id="4" name="TextBox 3"/>
+              <a:t>CHAPTER 01</a:t>
+            </a:r>
+          </a:p>
+        </p:txBody>
+      </p:sp>
+      <p:sp>
+        <p:nvSpPr>
+          <p:cNvPr id="5" name="TextBox 4"/>
           <p:cNvSpPr txBox="1"/>
           <p:nvPr/>
         </p:nvSpPr>
         <p:spPr>
           <a:xfrm>
-            <a:off x="2423160" y="2697480"/>
-            <a:ext cx="9265615" cy="1463040"/>
+            <a:off x="777240" y="2743200"/>
+            <a:ext cx="10058400" cy="1828800"/>
           </a:xfrm>
           <a:prstGeom prst="rect">
             <a:avLst/>
@@ -3688,7 +4155,7 @@
           <a:p>
             <a:pPr algn="l"/>
             <a:r>
-              <a:rPr sz="4000" b="1" i="0">
+              <a:rPr sz="5200" b="1" i="0">
                 <a:solidFill>
                   <a:srgbClr val="0B2A4A"/>
                 </a:solidFill>
@@ -3728,7 +4195,7 @@
         <p:spPr>
           <a:xfrm>
             <a:off x="502920" y="548640"/>
-            <a:ext cx="11155680" cy="731520"/>
+            <a:ext cx="11155680" cy="822960"/>
           </a:xfrm>
           <a:prstGeom prst="rect">
             <a:avLst/>
@@ -3742,7 +4209,7 @@
           <a:lstStyle/>
           <a:p>
             <a:r>
-              <a:rPr sz="2800" b="1" i="0">
+              <a:rPr sz="3200" b="1" i="0">
                 <a:solidFill>
                   <a:srgbClr val="0B2A4A"/>
                 </a:solidFill>
@@ -3757,14 +4224,57 @@
       </p:sp>
       <p:sp>
         <p:nvSpPr>
-          <p:cNvPr id="3" name="TextBox 2"/>
+          <p:cNvPr id="3" name="Rectangle 2"/>
+          <p:cNvSpPr/>
+          <p:nvPr/>
+        </p:nvSpPr>
+        <p:spPr>
+          <a:xfrm>
+            <a:off x="502920" y="1729740"/>
+            <a:ext cx="64008" cy="685800"/>
+          </a:xfrm>
+          <a:prstGeom prst="rect">
+            <a:avLst/>
+          </a:prstGeom>
+          <a:solidFill>
+            <a:srgbClr val="0A52BF"/>
+          </a:solidFill>
+          <a:ln>
+            <a:noFill/>
+          </a:ln>
+        </p:spPr>
+        <p:style>
+          <a:lnRef idx="1">
+            <a:schemeClr val="accent1"/>
+          </a:lnRef>
+          <a:fillRef idx="3">
+            <a:schemeClr val="accent1"/>
+          </a:fillRef>
+          <a:effectRef idx="2">
+            <a:schemeClr val="accent1"/>
+          </a:effectRef>
+          <a:fontRef idx="minor">
+            <a:schemeClr val="lt1"/>
+          </a:fontRef>
+        </p:style>
+        <p:txBody>
+          <a:bodyPr rtlCol="0" anchor="ctr"/>
+          <a:lstStyle/>
+          <a:p>
+            <a:pPr algn="ctr"/>
+          </a:p>
+        </p:txBody>
+      </p:sp>
+      <p:sp>
+        <p:nvSpPr>
+          <p:cNvPr id="4" name="TextBox 3"/>
           <p:cNvSpPr txBox="1"/>
           <p:nvPr/>
         </p:nvSpPr>
         <p:spPr>
           <a:xfrm>
-            <a:off x="502920" y="3398520"/>
-            <a:ext cx="11185855" cy="883920"/>
+            <a:off x="758952" y="1280160"/>
+            <a:ext cx="10929823" cy="1584960"/>
           </a:xfrm>
           <a:prstGeom prst="rect">
             <a:avLst/>
@@ -3772,31 +4282,16 @@
           <a:noFill/>
         </p:spPr>
         <p:txBody>
-          <a:bodyPr wrap="square" lIns="0" rIns="0" tIns="0" bIns="0">
+          <a:bodyPr wrap="square" lIns="0" rIns="0" tIns="0" bIns="0" anchor="ctr">
             <a:spAutoFit/>
           </a:bodyPr>
           <a:lstStyle/>
           <a:p>
-            <a:pPr>
-              <a:lnSpc>
-                <a:spcPct val="145000"/>
-              </a:lnSpc>
-            </a:pPr>
-            <a:r>
-              <a:rPr sz="1600" b="1" i="0">
+            <a:pPr algn="l"/>
+            <a:r>
+              <a:rPr sz="2600" b="0" i="0">
                 <a:solidFill>
-                  <a:srgbClr val="1E6FE0"/>
-                </a:solidFill>
-                <a:latin typeface="Microsoft YaHei"/>
-                <a:ea typeface="Microsoft YaHei"/>
-                <a:cs typeface="Microsoft YaHei"/>
-              </a:rPr>
-              <a:t>▎ </a:t>
-            </a:r>
-            <a:r>
-              <a:rPr sz="1600" b="0" i="0">
-                <a:solidFill>
-                  <a:srgbClr val="1A1A1A"/>
+                  <a:srgbClr val="4A4A4A"/>
                 </a:solidFill>
                 <a:latin typeface="Microsoft YaHei"/>
                 <a:ea typeface="Microsoft YaHei"/>
@@ -3805,27 +4300,78 @@
               <a:t>文字墙</a:t>
             </a:r>
           </a:p>
-          <a:p>
-            <a:pPr>
-              <a:lnSpc>
-                <a:spcPct val="145000"/>
-              </a:lnSpc>
-            </a:pPr>
-            <a:r>
-              <a:rPr sz="1600" b="1" i="0">
+        </p:txBody>
+      </p:sp>
+      <p:sp>
+        <p:nvSpPr>
+          <p:cNvPr id="5" name="Rectangle 4"/>
+          <p:cNvSpPr/>
+          <p:nvPr/>
+        </p:nvSpPr>
+        <p:spPr>
+          <a:xfrm>
+            <a:off x="502920" y="3314700"/>
+            <a:ext cx="64008" cy="685800"/>
+          </a:xfrm>
+          <a:prstGeom prst="rect">
+            <a:avLst/>
+          </a:prstGeom>
+          <a:solidFill>
+            <a:srgbClr val="0A52BF"/>
+          </a:solidFill>
+          <a:ln>
+            <a:noFill/>
+          </a:ln>
+        </p:spPr>
+        <p:style>
+          <a:lnRef idx="1">
+            <a:schemeClr val="accent1"/>
+          </a:lnRef>
+          <a:fillRef idx="3">
+            <a:schemeClr val="accent1"/>
+          </a:fillRef>
+          <a:effectRef idx="2">
+            <a:schemeClr val="accent1"/>
+          </a:effectRef>
+          <a:fontRef idx="minor">
+            <a:schemeClr val="lt1"/>
+          </a:fontRef>
+        </p:style>
+        <p:txBody>
+          <a:bodyPr rtlCol="0" anchor="ctr"/>
+          <a:lstStyle/>
+          <a:p>
+            <a:pPr algn="ctr"/>
+          </a:p>
+        </p:txBody>
+      </p:sp>
+      <p:sp>
+        <p:nvSpPr>
+          <p:cNvPr id="6" name="TextBox 5"/>
+          <p:cNvSpPr txBox="1"/>
+          <p:nvPr/>
+        </p:nvSpPr>
+        <p:spPr>
+          <a:xfrm>
+            <a:off x="758952" y="2865120"/>
+            <a:ext cx="10929823" cy="1584960"/>
+          </a:xfrm>
+          <a:prstGeom prst="rect">
+            <a:avLst/>
+          </a:prstGeom>
+          <a:noFill/>
+        </p:spPr>
+        <p:txBody>
+          <a:bodyPr wrap="square" lIns="0" rIns="0" tIns="0" bIns="0" anchor="ctr">
+            <a:spAutoFit/>
+          </a:bodyPr>
+          <a:lstStyle/>
+          <a:p>
+            <a:pPr algn="l"/>
+            <a:r>
+              <a:rPr sz="2600" b="0" i="0">
                 <a:solidFill>
-                  <a:srgbClr val="1E6FE0"/>
-                </a:solidFill>
-                <a:latin typeface="Microsoft YaHei"/>
-                <a:ea typeface="Microsoft YaHei"/>
-                <a:cs typeface="Microsoft YaHei"/>
-              </a:rPr>
-              <a:t>▎ </a:t>
-            </a:r>
-            <a:r>
-              <a:rPr sz="1600" b="0" i="0">
-                <a:solidFill>
-                  <a:srgbClr val="1A1A1A"/>
+                  <a:srgbClr val="4A4A4A"/>
                 </a:solidFill>
                 <a:latin typeface="Microsoft YaHei"/>
                 <a:ea typeface="Microsoft YaHei"/>
@@ -3834,27 +4380,78 @@
               <a:t>留白多</a:t>
             </a:r>
           </a:p>
-          <a:p>
-            <a:pPr>
-              <a:lnSpc>
-                <a:spcPct val="145000"/>
-              </a:lnSpc>
-            </a:pPr>
-            <a:r>
-              <a:rPr sz="1600" b="1" i="0">
+        </p:txBody>
+      </p:sp>
+      <p:sp>
+        <p:nvSpPr>
+          <p:cNvPr id="7" name="Rectangle 6"/>
+          <p:cNvSpPr/>
+          <p:nvPr/>
+        </p:nvSpPr>
+        <p:spPr>
+          <a:xfrm>
+            <a:off x="502920" y="4899660"/>
+            <a:ext cx="64008" cy="685800"/>
+          </a:xfrm>
+          <a:prstGeom prst="rect">
+            <a:avLst/>
+          </a:prstGeom>
+          <a:solidFill>
+            <a:srgbClr val="0A52BF"/>
+          </a:solidFill>
+          <a:ln>
+            <a:noFill/>
+          </a:ln>
+        </p:spPr>
+        <p:style>
+          <a:lnRef idx="1">
+            <a:schemeClr val="accent1"/>
+          </a:lnRef>
+          <a:fillRef idx="3">
+            <a:schemeClr val="accent1"/>
+          </a:fillRef>
+          <a:effectRef idx="2">
+            <a:schemeClr val="accent1"/>
+          </a:effectRef>
+          <a:fontRef idx="minor">
+            <a:schemeClr val="lt1"/>
+          </a:fontRef>
+        </p:style>
+        <p:txBody>
+          <a:bodyPr rtlCol="0" anchor="ctr"/>
+          <a:lstStyle/>
+          <a:p>
+            <a:pPr algn="ctr"/>
+          </a:p>
+        </p:txBody>
+      </p:sp>
+      <p:sp>
+        <p:nvSpPr>
+          <p:cNvPr id="8" name="TextBox 7"/>
+          <p:cNvSpPr txBox="1"/>
+          <p:nvPr/>
+        </p:nvSpPr>
+        <p:spPr>
+          <a:xfrm>
+            <a:off x="758952" y="4450080"/>
+            <a:ext cx="10929823" cy="1584960"/>
+          </a:xfrm>
+          <a:prstGeom prst="rect">
+            <a:avLst/>
+          </a:prstGeom>
+          <a:noFill/>
+        </p:spPr>
+        <p:txBody>
+          <a:bodyPr wrap="square" lIns="0" rIns="0" tIns="0" bIns="0" anchor="ctr">
+            <a:spAutoFit/>
+          </a:bodyPr>
+          <a:lstStyle/>
+          <a:p>
+            <a:pPr algn="l"/>
+            <a:r>
+              <a:rPr sz="2600" b="0" i="0">
                 <a:solidFill>
-                  <a:srgbClr val="1E6FE0"/>
-                </a:solidFill>
-                <a:latin typeface="Microsoft YaHei"/>
-                <a:ea typeface="Microsoft YaHei"/>
-                <a:cs typeface="Microsoft YaHei"/>
-              </a:rPr>
-              <a:t>▎ </a:t>
-            </a:r>
-            <a:r>
-              <a:rPr sz="1600" b="0" i="0">
-                <a:solidFill>
-                  <a:srgbClr val="1A1A1A"/>
+                  <a:srgbClr val="4A4A4A"/>
                 </a:solidFill>
                 <a:latin typeface="Microsoft YaHei"/>
                 <a:ea typeface="Microsoft YaHei"/>
@@ -3867,7 +4464,7 @@
       </p:sp>
       <p:sp>
         <p:nvSpPr>
-          <p:cNvPr id="4" name="Rectangle 3"/>
+          <p:cNvPr id="9" name="Rectangle 8"/>
           <p:cNvSpPr/>
           <p:nvPr/>
         </p:nvSpPr>
@@ -3910,7 +4507,7 @@
       </p:sp>
       <p:sp>
         <p:nvSpPr>
-          <p:cNvPr id="5" name="TextBox 4"/>
+          <p:cNvPr id="10" name="TextBox 9"/>
           <p:cNvSpPr txBox="1"/>
           <p:nvPr/>
         </p:nvSpPr>
@@ -3938,7 +4535,7 @@
             <a:r>
               <a:rPr sz="900" b="0" i="0">
                 <a:solidFill>
-                  <a:srgbClr val="8C8C8C"/>
+                  <a:srgbClr val="6F6F6F"/>
                 </a:solidFill>
                 <a:latin typeface="Helvetica Neue"/>
                 <a:ea typeface="Helvetica Neue"/>
@@ -3976,7 +4573,7 @@
         <p:spPr>
           <a:xfrm>
             <a:off x="502920" y="548640"/>
-            <a:ext cx="11155680" cy="731520"/>
+            <a:ext cx="11155680" cy="822960"/>
           </a:xfrm>
           <a:prstGeom prst="rect">
             <a:avLst/>
@@ -3990,7 +4587,7 @@
           <a:lstStyle/>
           <a:p>
             <a:r>
-              <a:rPr sz="2800" b="1" i="0">
+              <a:rPr sz="3200" b="1" i="0">
                 <a:solidFill>
                   <a:srgbClr val="0B2A4A"/>
                 </a:solidFill>
@@ -4067,7 +4664,7 @@
             </a:avLst>
           </a:prstGeom>
           <a:solidFill>
-            <a:srgbClr val="1E6FE0"/>
+            <a:srgbClr val="0A52BF"/>
           </a:solidFill>
           <a:ln>
             <a:noFill/>
@@ -4103,8 +4700,8 @@
         </p:nvSpPr>
         <p:spPr>
           <a:xfrm>
-            <a:off x="777240" y="2514600"/>
-            <a:ext cx="2997098" cy="457200"/>
+            <a:off x="777240" y="3179064"/>
+            <a:ext cx="2997098" cy="548640"/>
           </a:xfrm>
           <a:prstGeom prst="rect">
             <a:avLst/>
@@ -4112,14 +4709,14 @@
           <a:noFill/>
         </p:spPr>
         <p:txBody>
-          <a:bodyPr wrap="square" lIns="0" rIns="0" tIns="0" bIns="0">
+          <a:bodyPr wrap="square" lIns="0" rIns="0" tIns="0" bIns="0" anchor="ctr">
             <a:spAutoFit/>
           </a:bodyPr>
           <a:lstStyle/>
           <a:p>
             <a:pPr algn="l"/>
             <a:r>
-              <a:rPr sz="1800" b="1" i="0">
+              <a:rPr sz="2000" b="1" i="0">
                 <a:solidFill>
                   <a:srgbClr val="0B2A4A"/>
                 </a:solidFill>
@@ -4140,8 +4737,8 @@
         </p:nvSpPr>
         <p:spPr>
           <a:xfrm>
-            <a:off x="777240" y="3108960"/>
-            <a:ext cx="2997098" cy="1828800"/>
+            <a:off x="777240" y="3892296"/>
+            <a:ext cx="2997098" cy="609600"/>
           </a:xfrm>
           <a:prstGeom prst="rect">
             <a:avLst/>
@@ -4156,9 +4753,9 @@
           <a:p>
             <a:pPr algn="l"/>
             <a:r>
-              <a:rPr sz="1300" b="0" i="0">
+              <a:rPr sz="1600" b="0" i="0">
                 <a:solidFill>
-                  <a:srgbClr val="1A1A1A"/>
+                  <a:srgbClr val="4A4A4A"/>
                 </a:solidFill>
                 <a:latin typeface="Microsoft YaHei"/>
                 <a:ea typeface="Microsoft YaHei"/>
@@ -4233,7 +4830,7 @@
             </a:avLst>
           </a:prstGeom>
           <a:solidFill>
-            <a:srgbClr val="1E6FE0"/>
+            <a:srgbClr val="0A52BF"/>
           </a:solidFill>
           <a:ln>
             <a:noFill/>
@@ -4269,8 +4866,8 @@
         </p:nvSpPr>
         <p:spPr>
           <a:xfrm>
-            <a:off x="4597298" y="2514600"/>
-            <a:ext cx="2997098" cy="457200"/>
+            <a:off x="4597298" y="3179064"/>
+            <a:ext cx="2997098" cy="548640"/>
           </a:xfrm>
           <a:prstGeom prst="rect">
             <a:avLst/>
@@ -4278,14 +4875,14 @@
           <a:noFill/>
         </p:spPr>
         <p:txBody>
-          <a:bodyPr wrap="square" lIns="0" rIns="0" tIns="0" bIns="0">
+          <a:bodyPr wrap="square" lIns="0" rIns="0" tIns="0" bIns="0" anchor="ctr">
             <a:spAutoFit/>
           </a:bodyPr>
           <a:lstStyle/>
           <a:p>
             <a:pPr algn="l"/>
             <a:r>
-              <a:rPr sz="1800" b="1" i="0">
+              <a:rPr sz="2000" b="1" i="0">
                 <a:solidFill>
                   <a:srgbClr val="0B2A4A"/>
                 </a:solidFill>
@@ -4306,8 +4903,8 @@
         </p:nvSpPr>
         <p:spPr>
           <a:xfrm>
-            <a:off x="4597298" y="3108960"/>
-            <a:ext cx="2997098" cy="1828800"/>
+            <a:off x="4597298" y="3892296"/>
+            <a:ext cx="2997098" cy="609600"/>
           </a:xfrm>
           <a:prstGeom prst="rect">
             <a:avLst/>
@@ -4322,9 +4919,9 @@
           <a:p>
             <a:pPr algn="l"/>
             <a:r>
-              <a:rPr sz="1300" b="0" i="0">
+              <a:rPr sz="1600" b="0" i="0">
                 <a:solidFill>
-                  <a:srgbClr val="1A1A1A"/>
+                  <a:srgbClr val="4A4A4A"/>
                 </a:solidFill>
                 <a:latin typeface="Microsoft YaHei"/>
                 <a:ea typeface="Microsoft YaHei"/>
@@ -4399,7 +4996,7 @@
             </a:avLst>
           </a:prstGeom>
           <a:solidFill>
-            <a:srgbClr val="1E6FE0"/>
+            <a:srgbClr val="0A52BF"/>
           </a:solidFill>
           <a:ln>
             <a:noFill/>
@@ -4435,8 +5032,8 @@
         </p:nvSpPr>
         <p:spPr>
           <a:xfrm>
-            <a:off x="8417356" y="2514600"/>
-            <a:ext cx="2997098" cy="457200"/>
+            <a:off x="8417356" y="3331464"/>
+            <a:ext cx="2997098" cy="548640"/>
           </a:xfrm>
           <a:prstGeom prst="rect">
             <a:avLst/>
@@ -4444,14 +5041,14 @@
           <a:noFill/>
         </p:spPr>
         <p:txBody>
-          <a:bodyPr wrap="square" lIns="0" rIns="0" tIns="0" bIns="0">
+          <a:bodyPr wrap="square" lIns="0" rIns="0" tIns="0" bIns="0" anchor="ctr">
             <a:spAutoFit/>
           </a:bodyPr>
           <a:lstStyle/>
           <a:p>
             <a:pPr algn="l"/>
             <a:r>
-              <a:rPr sz="1800" b="1" i="0">
+              <a:rPr sz="2000" b="1" i="0">
                 <a:solidFill>
                   <a:srgbClr val="0B2A4A"/>
                 </a:solidFill>
@@ -4472,8 +5069,8 @@
         </p:nvSpPr>
         <p:spPr>
           <a:xfrm>
-            <a:off x="8417356" y="3108960"/>
-            <a:ext cx="2997098" cy="1828800"/>
+            <a:off x="8417356" y="4044696"/>
+            <a:ext cx="2997098" cy="304800"/>
           </a:xfrm>
           <a:prstGeom prst="rect">
             <a:avLst/>
@@ -4488,9 +5085,9 @@
           <a:p>
             <a:pPr algn="l"/>
             <a:r>
-              <a:rPr sz="1300" b="0" i="0">
+              <a:rPr sz="1600" b="0" i="0">
                 <a:solidFill>
-                  <a:srgbClr val="1A1A1A"/>
+                  <a:srgbClr val="4A4A4A"/>
                 </a:solidFill>
                 <a:latin typeface="Microsoft YaHei"/>
                 <a:ea typeface="Microsoft YaHei"/>
@@ -4574,7 +5171,7 @@
             <a:r>
               <a:rPr sz="900" b="0" i="0">
                 <a:solidFill>
-                  <a:srgbClr val="8C8C8C"/>
+                  <a:srgbClr val="6F6F6F"/>
                 </a:solidFill>
                 <a:latin typeface="Helvetica Neue"/>
                 <a:ea typeface="Helvetica Neue"/>
@@ -4612,7 +5209,7 @@
         <p:spPr>
           <a:xfrm>
             <a:off x="502920" y="548640"/>
-            <a:ext cx="11155680" cy="731520"/>
+            <a:ext cx="11155680" cy="822960"/>
           </a:xfrm>
           <a:prstGeom prst="rect">
             <a:avLst/>
@@ -4626,7 +5223,7 @@
           <a:lstStyle/>
           <a:p>
             <a:r>
-              <a:rPr sz="2800" b="1" i="0">
+              <a:rPr sz="3200" b="1" i="0">
                 <a:solidFill>
                   <a:srgbClr val="0B2A4A"/>
                 </a:solidFill>
@@ -4641,27 +5238,23 @@
       </p:sp>
       <p:sp>
         <p:nvSpPr>
-          <p:cNvPr id="3" name="Rounded Rectangle 2"/>
+          <p:cNvPr id="3" name="Rectangle 2"/>
           <p:cNvSpPr/>
           <p:nvPr/>
         </p:nvSpPr>
         <p:spPr>
           <a:xfrm>
-            <a:off x="502920" y="2286000"/>
-            <a:ext cx="5455767" cy="3108960"/>
-          </a:xfrm>
-          <a:prstGeom prst="roundRect">
-            <a:avLst>
-              <a:gd name="adj" fmla="val 5000"/>
-            </a:avLst>
+            <a:off x="502920" y="2240280"/>
+            <a:ext cx="5524347" cy="640080"/>
+          </a:xfrm>
+          <a:prstGeom prst="rect">
+            <a:avLst/>
           </a:prstGeom>
           <a:solidFill>
-            <a:srgbClr val="FFFFFF"/>
+            <a:srgbClr val="D9D9D9"/>
           </a:solidFill>
-          <a:ln w="9525">
-            <a:solidFill>
-              <a:srgbClr val="D9D9D9"/>
-            </a:solidFill>
+          <a:ln>
+            <a:noFill/>
           </a:ln>
         </p:spPr>
         <p:style>
@@ -4688,59 +5281,14 @@
       </p:sp>
       <p:sp>
         <p:nvSpPr>
-          <p:cNvPr id="4" name="Rounded Rectangle 3"/>
-          <p:cNvSpPr/>
-          <p:nvPr/>
-        </p:nvSpPr>
-        <p:spPr>
-          <a:xfrm>
-            <a:off x="502920" y="2286000"/>
-            <a:ext cx="36576" cy="3108960"/>
-          </a:xfrm>
-          <a:prstGeom prst="roundRect">
-            <a:avLst>
-              <a:gd name="adj" fmla="val 5000"/>
-            </a:avLst>
-          </a:prstGeom>
-          <a:solidFill>
-            <a:srgbClr val="1E6FE0"/>
-          </a:solidFill>
-          <a:ln>
-            <a:noFill/>
-          </a:ln>
-        </p:spPr>
-        <p:style>
-          <a:lnRef idx="1">
-            <a:schemeClr val="accent1"/>
-          </a:lnRef>
-          <a:fillRef idx="3">
-            <a:schemeClr val="accent1"/>
-          </a:fillRef>
-          <a:effectRef idx="2">
-            <a:schemeClr val="accent1"/>
-          </a:effectRef>
-          <a:fontRef idx="minor">
-            <a:schemeClr val="lt1"/>
-          </a:fontRef>
-        </p:style>
-        <p:txBody>
-          <a:bodyPr rtlCol="0" anchor="ctr"/>
-          <a:lstStyle/>
-          <a:p>
-            <a:pPr algn="ctr"/>
-          </a:p>
-        </p:txBody>
-      </p:sp>
-      <p:sp>
-        <p:nvSpPr>
-          <p:cNvPr id="5" name="TextBox 4"/>
+          <p:cNvPr id="4" name="TextBox 3"/>
           <p:cNvSpPr txBox="1"/>
           <p:nvPr/>
         </p:nvSpPr>
         <p:spPr>
           <a:xfrm>
-            <a:off x="777240" y="2514600"/>
-            <a:ext cx="4907127" cy="457200"/>
+            <a:off x="502920" y="2240280"/>
+            <a:ext cx="5524347" cy="640080"/>
           </a:xfrm>
           <a:prstGeom prst="rect">
             <a:avLst/>
@@ -4753,7 +5301,7 @@
           </a:bodyPr>
           <a:lstStyle/>
           <a:p>
-            <a:pPr algn="l"/>
+            <a:pPr algn="ctr"/>
             <a:r>
               <a:rPr sz="1800" b="1" i="0">
                 <a:solidFill>
@@ -4770,56 +5318,17 @@
       </p:sp>
       <p:sp>
         <p:nvSpPr>
-          <p:cNvPr id="6" name="TextBox 5"/>
-          <p:cNvSpPr txBox="1"/>
-          <p:nvPr/>
-        </p:nvSpPr>
-        <p:spPr>
-          <a:xfrm>
-            <a:off x="777240" y="3108960"/>
-            <a:ext cx="4907127" cy="1828800"/>
-          </a:xfrm>
-          <a:prstGeom prst="rect">
-            <a:avLst/>
-          </a:prstGeom>
-          <a:noFill/>
-        </p:spPr>
-        <p:txBody>
-          <a:bodyPr wrap="square" lIns="0" rIns="0" tIns="0" bIns="0">
-            <a:spAutoFit/>
-          </a:bodyPr>
-          <a:lstStyle/>
-          <a:p>
-            <a:pPr algn="l"/>
-            <a:r>
-              <a:rPr sz="1300" b="0" i="0">
-                <a:solidFill>
-                  <a:srgbClr val="1A1A1A"/>
-                </a:solidFill>
-                <a:latin typeface="Microsoft YaHei"/>
-                <a:ea typeface="Microsoft YaHei"/>
-                <a:cs typeface="Microsoft YaHei"/>
-              </a:rPr>
-              <a:t>骑墙,占位骨架</a:t>
-            </a:r>
-          </a:p>
-        </p:txBody>
-      </p:sp>
-      <p:sp>
-        <p:nvSpPr>
-          <p:cNvPr id="7" name="Rounded Rectangle 6"/>
+          <p:cNvPr id="5" name="Rectangle 4"/>
           <p:cNvSpPr/>
           <p:nvPr/>
         </p:nvSpPr>
         <p:spPr>
           <a:xfrm>
-            <a:off x="6233007" y="2286000"/>
-            <a:ext cx="5455767" cy="3108960"/>
-          </a:xfrm>
-          <a:prstGeom prst="roundRect">
-            <a:avLst>
-              <a:gd name="adj" fmla="val 5000"/>
-            </a:avLst>
+            <a:off x="502920" y="2880360"/>
+            <a:ext cx="5524347" cy="2560320"/>
+          </a:xfrm>
+          <a:prstGeom prst="rect">
+            <a:avLst/>
           </a:prstGeom>
           <a:solidFill>
             <a:srgbClr val="FFFFFF"/>
@@ -4854,22 +5363,57 @@
       </p:sp>
       <p:sp>
         <p:nvSpPr>
-          <p:cNvPr id="8" name="Rounded Rectangle 7"/>
+          <p:cNvPr id="6" name="TextBox 5"/>
+          <p:cNvSpPr txBox="1"/>
+          <p:nvPr/>
+        </p:nvSpPr>
+        <p:spPr>
+          <a:xfrm>
+            <a:off x="731520" y="3108960"/>
+            <a:ext cx="5067147" cy="2103120"/>
+          </a:xfrm>
+          <a:prstGeom prst="rect">
+            <a:avLst/>
+          </a:prstGeom>
+          <a:noFill/>
+        </p:spPr>
+        <p:txBody>
+          <a:bodyPr wrap="square" lIns="0" rIns="0" tIns="0" bIns="0" anchor="ctr">
+            <a:spAutoFit/>
+          </a:bodyPr>
+          <a:lstStyle/>
+          <a:p>
+            <a:pPr algn="l"/>
+            <a:r>
+              <a:rPr sz="1600" b="0" i="0">
+                <a:solidFill>
+                  <a:srgbClr val="4A4A4A"/>
+                </a:solidFill>
+                <a:latin typeface="Microsoft YaHei"/>
+                <a:ea typeface="Microsoft YaHei"/>
+                <a:cs typeface="Microsoft YaHei"/>
+              </a:rPr>
+              <a:t>骑墙,占位骨架</a:t>
+            </a:r>
+          </a:p>
+        </p:txBody>
+      </p:sp>
+      <p:sp>
+        <p:nvSpPr>
+          <p:cNvPr id="7" name="Rectangle 6"/>
           <p:cNvSpPr/>
           <p:nvPr/>
         </p:nvSpPr>
         <p:spPr>
           <a:xfrm>
-            <a:off x="6233007" y="2286000"/>
-            <a:ext cx="36576" cy="3108960"/>
-          </a:xfrm>
-          <a:prstGeom prst="roundRect">
-            <a:avLst>
-              <a:gd name="adj" fmla="val 5000"/>
-            </a:avLst>
+            <a:off x="6164427" y="2240280"/>
+            <a:ext cx="5524347" cy="640080"/>
+          </a:xfrm>
+          <a:prstGeom prst="rect">
+            <a:avLst/>
           </a:prstGeom>
           <a:solidFill>
-            <a:srgbClr val="00D1C1"/>
+            <a:srgbClr val="D9D9D9"/>
           </a:solidFill>
           <a:ln>
             <a:noFill/>
@@ -4899,14 +5443,14 @@
       </p:sp>
       <p:sp>
         <p:nvSpPr>
-          <p:cNvPr id="9" name="TextBox 8"/>
+          <p:cNvPr id="8" name="TextBox 7"/>
           <p:cNvSpPr txBox="1"/>
           <p:nvPr/>
         </p:nvSpPr>
         <p:spPr>
           <a:xfrm>
-            <a:off x="6507327" y="2514600"/>
-            <a:ext cx="4907127" cy="457200"/>
+            <a:off x="6164427" y="2240280"/>
+            <a:ext cx="5524347" cy="640080"/>
           </a:xfrm>
           <a:prstGeom prst="rect">
             <a:avLst/>
@@ -4919,7 +5463,7 @@
           </a:bodyPr>
           <a:lstStyle/>
           <a:p>
-            <a:pPr algn="l"/>
+            <a:pPr algn="ctr"/>
             <a:r>
               <a:rPr sz="1800" b="1" i="0">
                 <a:solidFill>
@@ -4936,14 +5480,59 @@
       </p:sp>
       <p:sp>
         <p:nvSpPr>
+          <p:cNvPr id="9" name="Rectangle 8"/>
+          <p:cNvSpPr/>
+          <p:nvPr/>
+        </p:nvSpPr>
+        <p:spPr>
+          <a:xfrm>
+            <a:off x="6164427" y="2880360"/>
+            <a:ext cx="5524347" cy="2560320"/>
+          </a:xfrm>
+          <a:prstGeom prst="rect">
+            <a:avLst/>
+          </a:prstGeom>
+          <a:solidFill>
+            <a:srgbClr val="FFFFFF"/>
+          </a:solidFill>
+          <a:ln w="9525">
+            <a:solidFill>
+              <a:srgbClr val="D9D9D9"/>
+            </a:solidFill>
+          </a:ln>
+        </p:spPr>
+        <p:style>
+          <a:lnRef idx="1">
+            <a:schemeClr val="accent1"/>
+          </a:lnRef>
+          <a:fillRef idx="3">
+            <a:schemeClr val="accent1"/>
+          </a:fillRef>
+          <a:effectRef idx="2">
+            <a:schemeClr val="accent1"/>
+          </a:effectRef>
+          <a:fontRef idx="minor">
+            <a:schemeClr val="lt1"/>
+          </a:fontRef>
+        </p:style>
+        <p:txBody>
+          <a:bodyPr rtlCol="0" anchor="ctr"/>
+          <a:lstStyle/>
+          <a:p>
+            <a:pPr algn="ctr"/>
+          </a:p>
+        </p:txBody>
+      </p:sp>
+      <p:sp>
+        <p:nvSpPr>
           <p:cNvPr id="10" name="TextBox 9"/>
           <p:cNvSpPr txBox="1"/>
           <p:nvPr/>
         </p:nvSpPr>
         <p:spPr>
           <a:xfrm>
-            <a:off x="6507327" y="3108960"/>
-            <a:ext cx="4907127" cy="1828800"/>
+            <a:off x="6393027" y="3108960"/>
+            <a:ext cx="5067147" cy="2103120"/>
           </a:xfrm>
           <a:prstGeom prst="rect">
             <a:avLst/>
@@ -4951,16 +5540,16 @@
           <a:noFill/>
         </p:spPr>
         <p:txBody>
-          <a:bodyPr wrap="square" lIns="0" rIns="0" tIns="0" bIns="0">
+          <a:bodyPr wrap="square" lIns="0" rIns="0" tIns="0" bIns="0" anchor="ctr">
             <a:spAutoFit/>
           </a:bodyPr>
           <a:lstStyle/>
           <a:p>
             <a:pPr algn="l"/>
             <a:r>
-              <a:rPr sz="1300" b="0" i="0">
+              <a:rPr sz="1600" b="0" i="0">
                 <a:solidFill>
-                  <a:srgbClr val="1A1A1A"/>
+                  <a:srgbClr val="4A4A4A"/>
                 </a:solidFill>
                 <a:latin typeface="Microsoft YaHei"/>
                 <a:ea typeface="Microsoft YaHei"/>
@@ -5044,7 +5633,7 @@
             <a:r>
               <a:rPr sz="900" b="0" i="0">
                 <a:solidFill>
-                  <a:srgbClr val="8C8C8C"/>
+                  <a:srgbClr val="6F6F6F"/>
                 </a:solidFill>
                 <a:latin typeface="Helvetica Neue"/>
                 <a:ea typeface="Helvetica Neue"/>
@@ -5082,7 +5671,7 @@
         <p:spPr>
           <a:xfrm>
             <a:off x="502920" y="548640"/>
-            <a:ext cx="11155680" cy="731520"/>
+            <a:ext cx="11155680" cy="822960"/>
           </a:xfrm>
           <a:prstGeom prst="rect">
             <a:avLst/>
@@ -5096,7 +5685,7 @@
           <a:lstStyle/>
           <a:p>
             <a:r>
-              <a:rPr sz="3200" b="1" i="0">
+              <a:rPr sz="3600" b="1" i="0">
                 <a:solidFill>
                   <a:srgbClr val="0B2A4A"/>
                 </a:solidFill>
@@ -5117,14 +5706,14 @@
         </p:nvSpPr>
         <p:spPr>
           <a:xfrm>
-            <a:off x="502920" y="1280160"/>
-            <a:ext cx="822960" cy="1584960"/>
+            <a:off x="502920" y="2697480"/>
+            <a:ext cx="914400" cy="822960"/>
           </a:xfrm>
           <a:prstGeom prst="rect">
             <a:avLst/>
           </a:prstGeom>
           <a:solidFill>
-            <a:srgbClr val="1E6FE0"/>
+            <a:srgbClr val="0A52BF"/>
           </a:solidFill>
           <a:ln>
             <a:noFill/>
@@ -5160,8 +5749,8 @@
         </p:nvSpPr>
         <p:spPr>
           <a:xfrm>
-            <a:off x="502920" y="1280160"/>
-            <a:ext cx="822960" cy="1584960"/>
+            <a:off x="502920" y="2697480"/>
+            <a:ext cx="914400" cy="822960"/>
           </a:xfrm>
           <a:prstGeom prst="rect">
             <a:avLst/>
@@ -5169,14 +5758,14 @@
           <a:noFill/>
         </p:spPr>
         <p:txBody>
-          <a:bodyPr wrap="none" lIns="0" rIns="0" tIns="0" bIns="0">
+          <a:bodyPr wrap="none" lIns="0" rIns="0" tIns="0" bIns="0" anchor="ctr">
             <a:spAutoFit/>
           </a:bodyPr>
           <a:lstStyle/>
           <a:p>
             <a:pPr algn="ctr"/>
             <a:r>
-              <a:rPr sz="3200" b="1" i="0">
+              <a:rPr sz="3600" b="1" i="0">
                 <a:solidFill>
                   <a:srgbClr val="FFFFFF"/>
                 </a:solidFill>
@@ -5197,8 +5786,8 @@
         </p:nvSpPr>
         <p:spPr>
           <a:xfrm>
-            <a:off x="1554480" y="1280160"/>
-            <a:ext cx="10134295" cy="1584960"/>
+            <a:off x="1691640" y="2697480"/>
+            <a:ext cx="9997135" cy="822960"/>
           </a:xfrm>
           <a:prstGeom prst="rect">
             <a:avLst/>
@@ -5206,13 +5795,13 @@
           <a:noFill/>
         </p:spPr>
         <p:txBody>
-          <a:bodyPr wrap="none" lIns="0" rIns="0" tIns="0" bIns="0">
+          <a:bodyPr wrap="square" lIns="0" rIns="0" tIns="0" bIns="0" anchor="ctr">
             <a:spAutoFit/>
           </a:bodyPr>
           <a:lstStyle/>
           <a:p>
             <a:r>
-              <a:rPr sz="1800" b="0" i="0">
+              <a:rPr sz="2200" b="0" i="0">
                 <a:solidFill>
                   <a:srgbClr val="1A1A1A"/>
                 </a:solidFill>
@@ -5233,14 +5822,14 @@
         </p:nvSpPr>
         <p:spPr>
           <a:xfrm>
-            <a:off x="502920" y="3048000"/>
-            <a:ext cx="822960" cy="1584960"/>
+            <a:off x="502920" y="3749040"/>
+            <a:ext cx="914400" cy="822960"/>
           </a:xfrm>
           <a:prstGeom prst="rect">
             <a:avLst/>
           </a:prstGeom>
           <a:solidFill>
-            <a:srgbClr val="1E6FE0"/>
+            <a:srgbClr val="0A52BF"/>
           </a:solidFill>
           <a:ln>
             <a:noFill/>
@@ -5276,8 +5865,8 @@
         </p:nvSpPr>
         <p:spPr>
           <a:xfrm>
-            <a:off x="502920" y="3048000"/>
-            <a:ext cx="822960" cy="1584960"/>
+            <a:off x="502920" y="3749040"/>
+            <a:ext cx="914400" cy="822960"/>
           </a:xfrm>
           <a:prstGeom prst="rect">
             <a:avLst/>
@@ -5285,14 +5874,14 @@
           <a:noFill/>
         </p:spPr>
         <p:txBody>
-          <a:bodyPr wrap="none" lIns="0" rIns="0" tIns="0" bIns="0">
+          <a:bodyPr wrap="none" lIns="0" rIns="0" tIns="0" bIns="0" anchor="ctr">
             <a:spAutoFit/>
           </a:bodyPr>
           <a:lstStyle/>
           <a:p>
             <a:pPr algn="ctr"/>
             <a:r>
-              <a:rPr sz="3200" b="1" i="0">
+              <a:rPr sz="3600" b="1" i="0">
                 <a:solidFill>
                   <a:srgbClr val="FFFFFF"/>
                 </a:solidFill>
@@ -5313,8 +5902,8 @@
         </p:nvSpPr>
         <p:spPr>
           <a:xfrm>
-            <a:off x="1554480" y="3048000"/>
-            <a:ext cx="10134295" cy="1584960"/>
+            <a:off x="1691640" y="3749040"/>
+            <a:ext cx="9997135" cy="822960"/>
           </a:xfrm>
           <a:prstGeom prst="rect">
             <a:avLst/>
@@ -5322,13 +5911,13 @@
           <a:noFill/>
         </p:spPr>
         <p:txBody>
-          <a:bodyPr wrap="none" lIns="0" rIns="0" tIns="0" bIns="0">
+          <a:bodyPr wrap="square" lIns="0" rIns="0" tIns="0" bIns="0" anchor="ctr">
             <a:spAutoFit/>
           </a:bodyPr>
           <a:lstStyle/>
           <a:p>
             <a:r>
-              <a:rPr sz="1800" b="0" i="0">
+              <a:rPr sz="2200" b="0" i="0">
                 <a:solidFill>
                   <a:srgbClr val="1A1A1A"/>
                 </a:solidFill>
@@ -5349,14 +5938,14 @@
         </p:nvSpPr>
         <p:spPr>
           <a:xfrm>
-            <a:off x="502920" y="4815840"/>
-            <a:ext cx="822960" cy="1584960"/>
+            <a:off x="502920" y="4800600"/>
+            <a:ext cx="914400" cy="822960"/>
           </a:xfrm>
           <a:prstGeom prst="rect">
             <a:avLst/>
           </a:prstGeom>
           <a:solidFill>
-            <a:srgbClr val="1E6FE0"/>
+            <a:srgbClr val="0A52BF"/>
           </a:solidFill>
           <a:ln>
             <a:noFill/>
@@ -5392,8 +5981,8 @@
         </p:nvSpPr>
         <p:spPr>
           <a:xfrm>
-            <a:off x="502920" y="4815840"/>
-            <a:ext cx="822960" cy="1584960"/>
+            <a:off x="502920" y="4800600"/>
+            <a:ext cx="914400" cy="822960"/>
           </a:xfrm>
           <a:prstGeom prst="rect">
             <a:avLst/>
@@ -5401,14 +5990,14 @@
           <a:noFill/>
         </p:spPr>
         <p:txBody>
-          <a:bodyPr wrap="none" lIns="0" rIns="0" tIns="0" bIns="0">
+          <a:bodyPr wrap="none" lIns="0" rIns="0" tIns="0" bIns="0" anchor="ctr">
             <a:spAutoFit/>
           </a:bodyPr>
           <a:lstStyle/>
           <a:p>
             <a:pPr algn="ctr"/>
             <a:r>
-              <a:rPr sz="3200" b="1" i="0">
+              <a:rPr sz="3600" b="1" i="0">
                 <a:solidFill>
                   <a:srgbClr val="FFFFFF"/>
                 </a:solidFill>
@@ -5429,8 +6018,8 @@
         </p:nvSpPr>
         <p:spPr>
           <a:xfrm>
-            <a:off x="1554480" y="4815840"/>
-            <a:ext cx="10134295" cy="1584960"/>
+            <a:off x="1691640" y="4800600"/>
+            <a:ext cx="9997135" cy="822960"/>
           </a:xfrm>
           <a:prstGeom prst="rect">
             <a:avLst/>
@@ -5438,13 +6027,13 @@
           <a:noFill/>
         </p:spPr>
         <p:txBody>
-          <a:bodyPr wrap="none" lIns="0" rIns="0" tIns="0" bIns="0">
+          <a:bodyPr wrap="square" lIns="0" rIns="0" tIns="0" bIns="0" anchor="ctr">
             <a:spAutoFit/>
           </a:bodyPr>
           <a:lstStyle/>
           <a:p>
             <a:r>
-              <a:rPr sz="1800" b="0" i="0">
+              <a:rPr sz="2200" b="0" i="0">
                 <a:solidFill>
                   <a:srgbClr val="1A1A1A"/>
                 </a:solidFill>
@@ -5530,7 +6119,7 @@
             <a:r>
               <a:rPr sz="900" b="0" i="0">
                 <a:solidFill>
-                  <a:srgbClr val="8C8C8C"/>
+                  <a:srgbClr val="6F6F6F"/>
                 </a:solidFill>
                 <a:latin typeface="Helvetica Neue"/>
                 <a:ea typeface="Helvetica Neue"/>
@@ -5626,7 +6215,7 @@
           <a:p>
             <a:pPr algn="ctr"/>
             <a:r>
-              <a:rPr sz="6400" b="1" i="0">
+              <a:rPr sz="7200" b="1" i="0">
                 <a:solidFill>
                   <a:srgbClr val="FFFFFF"/>
                 </a:solidFill>
@@ -5663,7 +6252,7 @@
           <a:p>
             <a:pPr algn="ctr"/>
             <a:r>
-              <a:rPr sz="1600" b="0" i="0">
+              <a:rPr sz="1800" b="0" i="0">
                 <a:solidFill>
                   <a:srgbClr val="E6F0FC"/>
                 </a:solidFill>

</xml_diff>